<commit_message>
fix(course): revise teaching logic and add reproducible demo materials
Rewrite Lesson 01 P03 around a concrete claim and its evidence gaps.
Separate result claims, mechanisms, measurement explanations, quality,
scope, and adoption decisions across the course. Add boardwork,
diagnostic feedback, and transitions to all 16 teaching plans.

Provide a deterministic reading-card replay package with source texts,
reference annotations, failure recovery, access checks, and evaluation;
connect it to writing and peer-review calibration materials.

Include the preceding uncommitted lesson 10-13 presentation corrections
and lesson 16 content-review record required by the lesson entrypoints.
The latest review changes remain in the content sources: PPT synchronization
and teacher approval are explicitly pending.

Validation: 12 course consistency checks, 5 workflow tests, internal links,
16 unchanged 90-minute schedules, and 313 continuous manuscript pages.
</commit_message>
<xml_diff>
--- a/lessons/lesson-10/slides.pptx
+++ b/lessons/lesson-10/slides.pptx
@@ -404,7 +404,7 @@
           <a:lstStyle xmlns:a="http://schemas.openxmlformats.org/drawingml/2006/main"/>
           <a:p xmlns:a="http://schemas.openxmlformats.org/drawingml/2006/main">
             <a:r>
-              <a:t>第 10 课受限执行。屏显按现行逐页母稿压缩为课堂可读对象，完整说明保留在讲义与教师备注。</a:t>
+              <a:t>第10讲 AI 辅助编码、调试与受限 Agent 执行</a:t>
             </a:r>
           </a:p>
           <a:p xmlns:a="http://schemas.openxmlformats.org/drawingml/2006/main">
@@ -414,17 +414,92 @@
           </a:p>
           <a:p xmlns:a="http://schemas.openxmlformats.org/drawingml/2006/main">
             <a:r>
+              <a:t>讲义对应：§导读；课程入口</a:t>
+            </a:r>
+          </a:p>
+          <a:p xmlns:a="http://schemas.openxmlformats.org/drawingml/2006/main">
+            <a:r>
+              <a:t/>
+            </a:r>
+          </a:p>
+          <a:p xmlns:a="http://schemas.openxmlformats.org/drawingml/2006/main">
+            <a:r>
+              <a:t>[Teaching]</a:t>
+            </a:r>
+          </a:p>
+          <a:p xmlns:a="http://schemas.openxmlformats.org/drawingml/2006/main">
+            <a:r>
+              <a:t>开场放下模糊 prompt。第 9 课判断门已过，项目进入阶段七原型验证。本课回答：Agent 帮忙改代码、跑测试、归因错误时，研究者在哪里审核、用什么权限、留什么记录，才能让"Agent 帮忙"不等于"Agent 替代判断"或"Agent 污染实验"。</a:t>
+            </a:r>
+          </a:p>
+          <a:p xmlns:a="http://schemas.openxmlformats.org/drawingml/2006/main">
+            <a:r>
+              <a:t/>
+            </a:r>
+          </a:p>
+          <a:p xmlns:a="http://schemas.openxmlformats.org/drawingml/2006/main">
+            <a:r>
+              <a:t>[Student action]</a:t>
+            </a:r>
+          </a:p>
+          <a:p xmlns:a="http://schemas.openxmlformats.org/drawingml/2006/main">
+            <a:r>
+              <a:t>不展开课程行政信息，直接进入下一页回扣。</a:t>
+            </a:r>
+          </a:p>
+          <a:p xmlns:a="http://schemas.openxmlformats.org/drawingml/2006/main">
+            <a:r>
+              <a:t/>
+            </a:r>
+          </a:p>
+          <a:p xmlns:a="http://schemas.openxmlformats.org/drawingml/2006/main">
+            <a:r>
+              <a:t>[Timing]</a:t>
+            </a:r>
+          </a:p>
+          <a:p xmlns:a="http://schemas.openxmlformats.org/drawingml/2006/main">
+            <a:r>
+              <a:t>3 分钟。</a:t>
+            </a:r>
+          </a:p>
+          <a:p xmlns:a="http://schemas.openxmlformats.org/drawingml/2006/main">
+            <a:r>
+              <a:t/>
+            </a:r>
+          </a:p>
+          <a:p xmlns:a="http://schemas.openxmlformats.org/drawingml/2006/main">
+            <a:r>
+              <a:t>[Evidence boundary]</a:t>
+            </a:r>
+          </a:p>
+          <a:p xmlns:a="http://schemas.openxmlformats.org/drawingml/2006/main">
+            <a:r>
+              <a:t>课程定位以 [syllabus.md](../../course/syllabus.md) 与 [备课规划.md](../备课规划.md) 第 10 课段为准。</a:t>
+            </a:r>
+          </a:p>
+          <a:p xmlns:a="http://schemas.openxmlformats.org/drawingml/2006/main">
+            <a:r>
+              <a:t/>
+            </a:r>
+          </a:p>
+          <a:p xmlns:a="http://schemas.openxmlformats.org/drawingml/2006/main">
+            <a:r>
               <a:t>[Sources]</a:t>
             </a:r>
           </a:p>
           <a:p xmlns:a="http://schemas.openxmlformats.org/drawingml/2006/main">
             <a:r>
-              <a:t>- /Users/bright/Projects/courses/graduate/lessons/lesson-10/slides.md</a:t>
-            </a:r>
-          </a:p>
-          <a:p xmlns:a="http://schemas.openxmlformats.org/drawingml/2006/main">
-            <a:r>
-              <a:t>- /Users/bright/Projects/courses/graduate/lessons/lesson-10/handout.md</a:t>
+              <a:t>- lessons/lesson-10/slides.md P01</a:t>
+            </a:r>
+          </a:p>
+          <a:p xmlns:a="http://schemas.openxmlformats.org/drawingml/2006/main">
+            <a:r>
+              <a:t>- lessons/lesson-10/handout.md §导读；课程入口</a:t>
+            </a:r>
+          </a:p>
+          <a:p xmlns:a="http://schemas.openxmlformats.org/drawingml/2006/main">
+            <a:r>
+              <a:t>- lessons/lesson-10/teaching-plan.md</a:t>
             </a:r>
           </a:p>
           <a:p xmlns:a="http://schemas.openxmlformats.org/drawingml/2006/main">
@@ -499,7 +574,7 @@
           <a:lstStyle xmlns:a="http://schemas.openxmlformats.org/drawingml/2006/main"/>
           <a:p xmlns:a="http://schemas.openxmlformats.org/drawingml/2006/main">
             <a:r>
-              <a:t>第 10 课受限执行。屏显按现行逐页母稿压缩为课堂可读对象，完整说明保留在讲义与教师备注。</a:t>
+              <a:t>SWE-bench 的测试判定仍不充分</a:t>
             </a:r>
           </a:p>
           <a:p xmlns:a="http://schemas.openxmlformats.org/drawingml/2006/main">
@@ -509,17 +584,107 @@
           </a:p>
           <a:p xmlns:a="http://schemas.openxmlformats.org/drawingml/2006/main">
             <a:r>
+              <a:t>讲义对应：§四·4 SWE-bench 视角</a:t>
+            </a:r>
+          </a:p>
+          <a:p xmlns:a="http://schemas.openxmlformats.org/drawingml/2006/main">
+            <a:r>
+              <a:t/>
+            </a:r>
+          </a:p>
+          <a:p xmlns:a="http://schemas.openxmlformats.org/drawingml/2006/main">
+            <a:r>
+              <a:t>[Teaching]</a:t>
+            </a:r>
+          </a:p>
+          <a:p xmlns:a="http://schemas.openxmlformats.org/drawingml/2006/main">
+            <a:r>
+              <a:t>SWE-bench 把"解决"定义为"测试通过"而非"代码看起来合理"，本课沿用这一判定。课程项目往往没有 SWE-bench 级别的测试集，因此研究者必须额外人工核验。测试通过不等于方法正确、不等于未引入数据泄漏、不等于未污染评价协议。SWE-bench 只分析任务构造与测试判定。</a:t>
+            </a:r>
+          </a:p>
+          <a:p xmlns:a="http://schemas.openxmlformats.org/drawingml/2006/main">
+            <a:r>
+              <a:t/>
+            </a:r>
+          </a:p>
+          <a:p xmlns:a="http://schemas.openxmlformats.org/drawingml/2006/main">
+            <a:r>
+              <a:t>[Student action]</a:t>
+            </a:r>
+          </a:p>
+          <a:p xmlns:a="http://schemas.openxmlformats.org/drawingml/2006/main">
+            <a:r>
+              <a:t>无。</a:t>
+            </a:r>
+          </a:p>
+          <a:p xmlns:a="http://schemas.openxmlformats.org/drawingml/2006/main">
+            <a:r>
+              <a:t/>
+            </a:r>
+          </a:p>
+          <a:p xmlns:a="http://schemas.openxmlformats.org/drawingml/2006/main">
+            <a:r>
+              <a:t>[Timing]</a:t>
+            </a:r>
+          </a:p>
+          <a:p xmlns:a="http://schemas.openxmlformats.org/drawingml/2006/main">
+            <a:r>
+              <a:t>3 分钟。</a:t>
+            </a:r>
+          </a:p>
+          <a:p xmlns:a="http://schemas.openxmlformats.org/drawingml/2006/main">
+            <a:r>
+              <a:t/>
+            </a:r>
+          </a:p>
+          <a:p xmlns:a="http://schemas.openxmlformats.org/drawingml/2006/main">
+            <a:r>
+              <a:t>[Evidence boundary]</a:t>
+            </a:r>
+          </a:p>
+          <a:p xmlns:a="http://schemas.openxmlformats.org/drawingml/2006/main">
+            <a:r>
+              <a:t>直接来源：[正式来源](https://www.swebench.com/original.html)。</a:t>
+            </a:r>
+          </a:p>
+          <a:p xmlns:a="http://schemas.openxmlformats.org/drawingml/2006/main">
+            <a:r>
+              <a:t/>
+            </a:r>
+          </a:p>
+          <a:p xmlns:a="http://schemas.openxmlformats.org/drawingml/2006/main">
+            <a:r>
+              <a:t>讲义 §四·4；Jimenez et al. SWE-bench ICLR 2024（[reading-list.md](../../course/reading-list.md) 第 10 课）。</a:t>
+            </a:r>
+          </a:p>
+          <a:p xmlns:a="http://schemas.openxmlformats.org/drawingml/2006/main">
+            <a:r>
+              <a:t/>
+            </a:r>
+          </a:p>
+          <a:p xmlns:a="http://schemas.openxmlformats.org/drawingml/2006/main">
+            <a:r>
               <a:t>[Sources]</a:t>
             </a:r>
           </a:p>
           <a:p xmlns:a="http://schemas.openxmlformats.org/drawingml/2006/main">
             <a:r>
-              <a:t>- /Users/bright/Projects/courses/graduate/lessons/lesson-10/slides.md</a:t>
-            </a:r>
-          </a:p>
-          <a:p xmlns:a="http://schemas.openxmlformats.org/drawingml/2006/main">
-            <a:r>
-              <a:t>- /Users/bright/Projects/courses/graduate/lessons/lesson-10/handout.md</a:t>
+              <a:t>- lessons/lesson-10/slides.md P10</a:t>
+            </a:r>
+          </a:p>
+          <a:p xmlns:a="http://schemas.openxmlformats.org/drawingml/2006/main">
+            <a:r>
+              <a:t>- lessons/lesson-10/handout.md §四·4 SWE-bench 视角</a:t>
+            </a:r>
+          </a:p>
+          <a:p xmlns:a="http://schemas.openxmlformats.org/drawingml/2006/main">
+            <a:r>
+              <a:t>- lessons/lesson-10/teaching-plan.md</a:t>
+            </a:r>
+          </a:p>
+          <a:p xmlns:a="http://schemas.openxmlformats.org/drawingml/2006/main">
+            <a:r>
+              <a:t>- https://www.swebench.com/original.html</a:t>
             </a:r>
           </a:p>
           <a:p xmlns:a="http://schemas.openxmlformats.org/drawingml/2006/main">
@@ -594,7 +759,7 @@
           <a:lstStyle xmlns:a="http://schemas.openxmlformats.org/drawingml/2006/main"/>
           <a:p xmlns:a="http://schemas.openxmlformats.org/drawingml/2006/main">
             <a:r>
-              <a:t>第 10 课受限执行。屏显按现行逐页母稿压缩为课堂可读对象，完整说明保留在讲义与教师备注。</a:t>
+              <a:t>同一实验规格进入受限执行</a:t>
             </a:r>
           </a:p>
           <a:p xmlns:a="http://schemas.openxmlformats.org/drawingml/2006/main">
@@ -604,17 +769,92 @@
           </a:p>
           <a:p xmlns:a="http://schemas.openxmlformats.org/drawingml/2006/main">
             <a:r>
+              <a:t>讲义对应：§五 贯穿案例第一至二步（实验规格标注 + 任务契约五字段）</a:t>
+            </a:r>
+          </a:p>
+          <a:p xmlns:a="http://schemas.openxmlformats.org/drawingml/2006/main">
+            <a:r>
+              <a:t/>
+            </a:r>
+          </a:p>
+          <a:p xmlns:a="http://schemas.openxmlformats.org/drawingml/2006/main">
+            <a:r>
+              <a:t>[Teaching]</a:t>
+            </a:r>
+          </a:p>
+          <a:p xmlns:a="http://schemas.openxmlformats.org/drawingml/2006/main">
+            <a:r>
+              <a:t>演示如何从第 9 课实验规格中标注的"拟用 Agent"步骤选出本课的受限任务——以冻结配置分别生成。任务契约五字段已在 P04 展示，本页只固定样本、条件、配置、评价隔离与追踪口径。重点：Context 不暴露人工基准与最终评分；规模和 H1/A1/A2/A3 编号沿用第 9 课，不在本课改写。</a:t>
+            </a:r>
+          </a:p>
+          <a:p xmlns:a="http://schemas.openxmlformats.org/drawingml/2006/main">
+            <a:r>
+              <a:t/>
+            </a:r>
+          </a:p>
+          <a:p xmlns:a="http://schemas.openxmlformats.org/drawingml/2006/main">
+            <a:r>
+              <a:t>[Student action]</a:t>
+            </a:r>
+          </a:p>
+          <a:p xmlns:a="http://schemas.openxmlformats.org/drawingml/2006/main">
+            <a:r>
+              <a:t>让学生用自己的实验规格标注"拟用 Agent"与"必须人工"步骤。</a:t>
+            </a:r>
+          </a:p>
+          <a:p xmlns:a="http://schemas.openxmlformats.org/drawingml/2006/main">
+            <a:r>
+              <a:t/>
+            </a:r>
+          </a:p>
+          <a:p xmlns:a="http://schemas.openxmlformats.org/drawingml/2006/main">
+            <a:r>
+              <a:t>[Timing]</a:t>
+            </a:r>
+          </a:p>
+          <a:p xmlns:a="http://schemas.openxmlformats.org/drawingml/2006/main">
+            <a:r>
+              <a:t>5 分钟。</a:t>
+            </a:r>
+          </a:p>
+          <a:p xmlns:a="http://schemas.openxmlformats.org/drawingml/2006/main">
+            <a:r>
+              <a:t/>
+            </a:r>
+          </a:p>
+          <a:p xmlns:a="http://schemas.openxmlformats.org/drawingml/2006/main">
+            <a:r>
+              <a:t>[Evidence boundary]</a:t>
+            </a:r>
+          </a:p>
+          <a:p xmlns:a="http://schemas.openxmlformats.org/drawingml/2006/main">
+            <a:r>
+              <a:t>讲义 §五 第一步与第二步；第 9 课实验规格。</a:t>
+            </a:r>
+          </a:p>
+          <a:p xmlns:a="http://schemas.openxmlformats.org/drawingml/2006/main">
+            <a:r>
+              <a:t/>
+            </a:r>
+          </a:p>
+          <a:p xmlns:a="http://schemas.openxmlformats.org/drawingml/2006/main">
+            <a:r>
               <a:t>[Sources]</a:t>
             </a:r>
           </a:p>
           <a:p xmlns:a="http://schemas.openxmlformats.org/drawingml/2006/main">
             <a:r>
-              <a:t>- /Users/bright/Projects/courses/graduate/lessons/lesson-10/slides.md</a:t>
-            </a:r>
-          </a:p>
-          <a:p xmlns:a="http://schemas.openxmlformats.org/drawingml/2006/main">
-            <a:r>
-              <a:t>- /Users/bright/Projects/courses/graduate/lessons/lesson-10/handout.md</a:t>
+              <a:t>- lessons/lesson-10/slides.md P11</a:t>
+            </a:r>
+          </a:p>
+          <a:p xmlns:a="http://schemas.openxmlformats.org/drawingml/2006/main">
+            <a:r>
+              <a:t>- lessons/lesson-10/handout.md §五 贯穿案例第一至二步（实验规格标注 + 任务契约五字段）</a:t>
+            </a:r>
+          </a:p>
+          <a:p xmlns:a="http://schemas.openxmlformats.org/drawingml/2006/main">
+            <a:r>
+              <a:t>- lessons/lesson-10/teaching-plan.md</a:t>
             </a:r>
           </a:p>
           <a:p xmlns:a="http://schemas.openxmlformats.org/drawingml/2006/main">
@@ -689,7 +929,7 @@
           <a:lstStyle xmlns:a="http://schemas.openxmlformats.org/drawingml/2006/main"/>
           <a:p xmlns:a="http://schemas.openxmlformats.org/drawingml/2006/main">
             <a:r>
-              <a:t>第 10 课受限执行。屏显按现行逐页母稿压缩为课堂可读对象，完整说明保留在讲义与教师备注。</a:t>
+              <a:t>diff、测试和失败日志形成一次 trace</a:t>
             </a:r>
           </a:p>
           <a:p xmlns:a="http://schemas.openxmlformats.org/drawingml/2006/main">
@@ -699,17 +939,117 @@
           </a:p>
           <a:p xmlns:a="http://schemas.openxmlformats.org/drawingml/2006/main">
             <a:r>
+              <a:t>讲义对应：§五 贯穿案例第三至四步（Agent 执行与人工核验 + 失败记录）；§五 第五步（写入项目）</a:t>
+            </a:r>
+          </a:p>
+          <a:p xmlns:a="http://schemas.openxmlformats.org/drawingml/2006/main">
+            <a:r>
+              <a:t/>
+            </a:r>
+          </a:p>
+          <a:p xmlns:a="http://schemas.openxmlformats.org/drawingml/2006/main">
+            <a:r>
+              <a:t>[Teaching]</a:t>
+            </a:r>
+          </a:p>
+          <a:p xmlns:a="http://schemas.openxmlformats.org/drawingml/2006/main">
+            <a:r>
+              <a:t>直接打开本课资产 `generate.diff`、`test-output.txt`与 `failure-log.md`，而不只讲虚构结果。三者分别对应代码候选、真实运行证据和越权决策。第五步：本课产出回写个人项目，任务契约写入 `agent-tasks/`，失败记录写入 `experiments/*/agent-traces/`，AI 使用记录沿用完整披露字段。</a:t>
+            </a:r>
+          </a:p>
+          <a:p xmlns:a="http://schemas.openxmlformats.org/drawingml/2006/main">
+            <a:r>
+              <a:t/>
+            </a:r>
+          </a:p>
+          <a:p xmlns:a="http://schemas.openxmlformats.org/drawingml/2006/main">
+            <a:r>
+              <a:t>[Student action]</a:t>
+            </a:r>
+          </a:p>
+          <a:p xmlns:a="http://schemas.openxmlformats.org/drawingml/2006/main">
+            <a:r>
+              <a:t>让学生尝试为自己的任务写一条失败记录。</a:t>
+            </a:r>
+          </a:p>
+          <a:p xmlns:a="http://schemas.openxmlformats.org/drawingml/2006/main">
+            <a:r>
+              <a:t/>
+            </a:r>
+          </a:p>
+          <a:p xmlns:a="http://schemas.openxmlformats.org/drawingml/2006/main">
+            <a:r>
+              <a:t>[Timing]</a:t>
+            </a:r>
+          </a:p>
+          <a:p xmlns:a="http://schemas.openxmlformats.org/drawingml/2006/main">
+            <a:r>
+              <a:t>7 分钟。</a:t>
+            </a:r>
+          </a:p>
+          <a:p xmlns:a="http://schemas.openxmlformats.org/drawingml/2006/main">
+            <a:r>
+              <a:t/>
+            </a:r>
+          </a:p>
+          <a:p xmlns:a="http://schemas.openxmlformats.org/drawingml/2006/main">
+            <a:r>
+              <a:t>[Evidence boundary]</a:t>
+            </a:r>
+          </a:p>
+          <a:p xmlns:a="http://schemas.openxmlformats.org/drawingml/2006/main">
+            <a:r>
+              <a:t>直接来源：[本课工件](assets/agent-task-example/generate.diff)；[本课工件](assets/agent-task-example/test-output.txt)；[本课工件](assets/agent-task-example/failure-log.md)。</a:t>
+            </a:r>
+          </a:p>
+          <a:p xmlns:a="http://schemas.openxmlformats.org/drawingml/2006/main">
+            <a:r>
+              <a:t/>
+            </a:r>
+          </a:p>
+          <a:p xmlns:a="http://schemas.openxmlformats.org/drawingml/2006/main">
+            <a:r>
+              <a:t>讲义 §五 第三步、第四步与第五步；[project-template.md](../../course/project-template.md) §6.1 任务契约；本课 `assets/agent-task-example/` 中的任务契约、真实 diff、测试输出与失败日志。</a:t>
+            </a:r>
+          </a:p>
+          <a:p xmlns:a="http://schemas.openxmlformats.org/drawingml/2006/main">
+            <a:r>
+              <a:t/>
+            </a:r>
+          </a:p>
+          <a:p xmlns:a="http://schemas.openxmlformats.org/drawingml/2006/main">
+            <a:r>
               <a:t>[Sources]</a:t>
             </a:r>
           </a:p>
           <a:p xmlns:a="http://schemas.openxmlformats.org/drawingml/2006/main">
             <a:r>
-              <a:t>- /Users/bright/Projects/courses/graduate/lessons/lesson-10/slides.md</a:t>
-            </a:r>
-          </a:p>
-          <a:p xmlns:a="http://schemas.openxmlformats.org/drawingml/2006/main">
-            <a:r>
-              <a:t>- /Users/bright/Projects/courses/graduate/lessons/lesson-10/handout.md</a:t>
+              <a:t>- lessons/lesson-10/slides.md P12</a:t>
+            </a:r>
+          </a:p>
+          <a:p xmlns:a="http://schemas.openxmlformats.org/drawingml/2006/main">
+            <a:r>
+              <a:t>- lessons/lesson-10/handout.md §五 贯穿案例第三至四步（Agent 执行与人工核验 + 失败记录）；§五 第五步（写入项目）</a:t>
+            </a:r>
+          </a:p>
+          <a:p xmlns:a="http://schemas.openxmlformats.org/drawingml/2006/main">
+            <a:r>
+              <a:t>- lessons/lesson-10/teaching-plan.md</a:t>
+            </a:r>
+          </a:p>
+          <a:p xmlns:a="http://schemas.openxmlformats.org/drawingml/2006/main">
+            <a:r>
+              <a:t>- assets/agent-task-example/generate.diff</a:t>
+            </a:r>
+          </a:p>
+          <a:p xmlns:a="http://schemas.openxmlformats.org/drawingml/2006/main">
+            <a:r>
+              <a:t>- assets/agent-task-example/test-output.txt</a:t>
+            </a:r>
+          </a:p>
+          <a:p xmlns:a="http://schemas.openxmlformats.org/drawingml/2006/main">
+            <a:r>
+              <a:t>- assets/agent-task-example/failure-log.md</a:t>
             </a:r>
           </a:p>
           <a:p xmlns:a="http://schemas.openxmlformats.org/drawingml/2006/main">
@@ -784,7 +1124,7 @@
           <a:lstStyle xmlns:a="http://schemas.openxmlformats.org/drawingml/2006/main"/>
           <a:p xmlns:a="http://schemas.openxmlformats.org/drawingml/2006/main">
             <a:r>
-              <a:t>第 10 课受限执行。屏显按现行逐页母稿压缩为课堂可读对象，完整说明保留在讲义与教师备注。</a:t>
+              <a:t>把一个 Agent 步骤改写为受限任务</a:t>
             </a:r>
           </a:p>
           <a:p xmlns:a="http://schemas.openxmlformats.org/drawingml/2006/main">
@@ -794,17 +1134,92 @@
           </a:p>
           <a:p xmlns:a="http://schemas.openxmlformats.org/drawingml/2006/main">
             <a:r>
+              <a:t>讲义对应：个人实践第一段：契约与权限 | 契约初版</a:t>
+            </a:r>
+          </a:p>
+          <a:p xmlns:a="http://schemas.openxmlformats.org/drawingml/2006/main">
+            <a:r>
+              <a:t/>
+            </a:r>
+          </a:p>
+          <a:p xmlns:a="http://schemas.openxmlformats.org/drawingml/2006/main">
+            <a:r>
+              <a:t>[Teaching]</a:t>
+            </a:r>
+          </a:p>
+          <a:p xmlns:a="http://schemas.openxmlformats.org/drawingml/2006/main">
+            <a:r>
+              <a:t>验收不再要求所有学生当场运行 Agent。环境就绪者审查自己的真实 diff 与测试输出；备用路径直接使用本课预置工件。两条路径都必须产出：任务契约、权限边界、diff 审查、一条验证证据、一条失败/越权决策与 AI 披露记录开头。</a:t>
+            </a:r>
+          </a:p>
+          <a:p xmlns:a="http://schemas.openxmlformats.org/drawingml/2006/main">
+            <a:r>
+              <a:t/>
+            </a:r>
+          </a:p>
+          <a:p xmlns:a="http://schemas.openxmlformats.org/drawingml/2006/main">
+            <a:r>
+              <a:t>[Student action]</a:t>
+            </a:r>
+          </a:p>
+          <a:p xmlns:a="http://schemas.openxmlformats.org/drawingml/2006/main">
+            <a:r>
+              <a:t>本页用于第一段个人实践。教师巡视只记录共性卡点，不逐台代为修正。</a:t>
+            </a:r>
+          </a:p>
+          <a:p xmlns:a="http://schemas.openxmlformats.org/drawingml/2006/main">
+            <a:r>
+              <a:t/>
+            </a:r>
+          </a:p>
+          <a:p xmlns:a="http://schemas.openxmlformats.org/drawingml/2006/main">
+            <a:r>
+              <a:t>[Timing]</a:t>
+            </a:r>
+          </a:p>
+          <a:p xmlns:a="http://schemas.openxmlformats.org/drawingml/2006/main">
+            <a:r>
+              <a:t>10 分钟。</a:t>
+            </a:r>
+          </a:p>
+          <a:p xmlns:a="http://schemas.openxmlformats.org/drawingml/2006/main">
+            <a:r>
+              <a:t/>
+            </a:r>
+          </a:p>
+          <a:p xmlns:a="http://schemas.openxmlformats.org/drawingml/2006/main">
+            <a:r>
+              <a:t>[Evidence boundary]</a:t>
+            </a:r>
+          </a:p>
+          <a:p xmlns:a="http://schemas.openxmlformats.org/drawingml/2006/main">
+            <a:r>
+              <a:t>[project-template.md](../../course/project-template.md) 字段模板；第 9 课实验规格。</a:t>
+            </a:r>
+          </a:p>
+          <a:p xmlns:a="http://schemas.openxmlformats.org/drawingml/2006/main">
+            <a:r>
+              <a:t/>
+            </a:r>
+          </a:p>
+          <a:p xmlns:a="http://schemas.openxmlformats.org/drawingml/2006/main">
+            <a:r>
               <a:t>[Sources]</a:t>
             </a:r>
           </a:p>
           <a:p xmlns:a="http://schemas.openxmlformats.org/drawingml/2006/main">
             <a:r>
-              <a:t>- /Users/bright/Projects/courses/graduate/lessons/lesson-10/slides.md</a:t>
-            </a:r>
-          </a:p>
-          <a:p xmlns:a="http://schemas.openxmlformats.org/drawingml/2006/main">
-            <a:r>
-              <a:t>- /Users/bright/Projects/courses/graduate/lessons/lesson-10/handout.md</a:t>
+              <a:t>- lessons/lesson-10/slides.md P13</a:t>
+            </a:r>
+          </a:p>
+          <a:p xmlns:a="http://schemas.openxmlformats.org/drawingml/2006/main">
+            <a:r>
+              <a:t>- lessons/lesson-10/handout.md 个人实践第一段：契约与权限 | 契约初版</a:t>
+            </a:r>
+          </a:p>
+          <a:p xmlns:a="http://schemas.openxmlformats.org/drawingml/2006/main">
+            <a:r>
+              <a:t>- lessons/lesson-10/teaching-plan.md</a:t>
             </a:r>
           </a:p>
           <a:p xmlns:a="http://schemas.openxmlformats.org/drawingml/2006/main">
@@ -879,7 +1294,7 @@
           <a:lstStyle xmlns:a="http://schemas.openxmlformats.org/drawingml/2006/main"/>
           <a:p xmlns:a="http://schemas.openxmlformats.org/drawingml/2006/main">
             <a:r>
-              <a:t>第 10 课受限执行。屏显按现行逐页母稿压缩为课堂可读对象，完整说明保留在讲义与教师备注。</a:t>
+              <a:t>文件落点与 diff 审查</a:t>
             </a:r>
           </a:p>
           <a:p xmlns:a="http://schemas.openxmlformats.org/drawingml/2006/main">
@@ -889,17 +1304,92 @@
           </a:p>
           <a:p xmlns:a="http://schemas.openxmlformats.org/drawingml/2006/main">
             <a:r>
+              <a:t>讲义对应：教师中点点评后继续实践：diff/测试审查与失败记录 | 审查与决定记录</a:t>
+            </a:r>
+          </a:p>
+          <a:p xmlns:a="http://schemas.openxmlformats.org/drawingml/2006/main">
+            <a:r>
+              <a:t/>
+            </a:r>
+          </a:p>
+          <a:p xmlns:a="http://schemas.openxmlformats.org/drawingml/2006/main">
+            <a:r>
+              <a:t>[Teaching]</a:t>
+            </a:r>
+          </a:p>
+          <a:p xmlns:a="http://schemas.openxmlformats.org/drawingml/2006/main">
+            <a:r>
+              <a:t>模板投屏停留。学生可照抄文件结构。本课产出任务契约、代码 diff、验证记录与失败记录，回写个人项目。Agent 执行可在课后用合规环境补做，但任务契约与失败记录必须在课堂内启动。</a:t>
+            </a:r>
+          </a:p>
+          <a:p xmlns:a="http://schemas.openxmlformats.org/drawingml/2006/main">
+            <a:r>
+              <a:t/>
+            </a:r>
+          </a:p>
+          <a:p xmlns:a="http://schemas.openxmlformats.org/drawingml/2006/main">
+            <a:r>
+              <a:t>[Student action]</a:t>
+            </a:r>
+          </a:p>
+          <a:p xmlns:a="http://schemas.openxmlformats.org/drawingml/2006/main">
+            <a:r>
+              <a:t>教师先点评权限过宽、验收不可测、评价代码未隔离三类共性问题；学生再继续第二段个人实践。</a:t>
+            </a:r>
+          </a:p>
+          <a:p xmlns:a="http://schemas.openxmlformats.org/drawingml/2006/main">
+            <a:r>
+              <a:t/>
+            </a:r>
+          </a:p>
+          <a:p xmlns:a="http://schemas.openxmlformats.org/drawingml/2006/main">
+            <a:r>
+              <a:t>[Timing]</a:t>
+            </a:r>
+          </a:p>
+          <a:p xmlns:a="http://schemas.openxmlformats.org/drawingml/2006/main">
+            <a:r>
+              <a:t>15 分钟（教师中点点评 5 分钟 + 个人实践 10 分钟）。</a:t>
+            </a:r>
+          </a:p>
+          <a:p xmlns:a="http://schemas.openxmlformats.org/drawingml/2006/main">
+            <a:r>
+              <a:t/>
+            </a:r>
+          </a:p>
+          <a:p xmlns:a="http://schemas.openxmlformats.org/drawingml/2006/main">
+            <a:r>
+              <a:t>[Evidence boundary]</a:t>
+            </a:r>
+          </a:p>
+          <a:p xmlns:a="http://schemas.openxmlformats.org/drawingml/2006/main">
+            <a:r>
+              <a:t>[project-template.md](../../course/project-template.md)；讲义 §五 第五步。</a:t>
+            </a:r>
+          </a:p>
+          <a:p xmlns:a="http://schemas.openxmlformats.org/drawingml/2006/main">
+            <a:r>
+              <a:t/>
+            </a:r>
+          </a:p>
+          <a:p xmlns:a="http://schemas.openxmlformats.org/drawingml/2006/main">
+            <a:r>
               <a:t>[Sources]</a:t>
             </a:r>
           </a:p>
           <a:p xmlns:a="http://schemas.openxmlformats.org/drawingml/2006/main">
             <a:r>
-              <a:t>- /Users/bright/Projects/courses/graduate/lessons/lesson-10/slides.md</a:t>
-            </a:r>
-          </a:p>
-          <a:p xmlns:a="http://schemas.openxmlformats.org/drawingml/2006/main">
-            <a:r>
-              <a:t>- /Users/bright/Projects/courses/graduate/lessons/lesson-10/handout.md</a:t>
+              <a:t>- lessons/lesson-10/slides.md P14</a:t>
+            </a:r>
+          </a:p>
+          <a:p xmlns:a="http://schemas.openxmlformats.org/drawingml/2006/main">
+            <a:r>
+              <a:t>- lessons/lesson-10/handout.md 教师中点点评后继续实践：diff/测试审查与失败记录 | 审查与决定记录</a:t>
+            </a:r>
+          </a:p>
+          <a:p xmlns:a="http://schemas.openxmlformats.org/drawingml/2006/main">
+            <a:r>
+              <a:t>- lessons/lesson-10/teaching-plan.md</a:t>
             </a:r>
           </a:p>
           <a:p xmlns:a="http://schemas.openxmlformats.org/drawingml/2006/main">
@@ -974,7 +1464,7 @@
           <a:lstStyle xmlns:a="http://schemas.openxmlformats.org/drawingml/2006/main"/>
           <a:p xmlns:a="http://schemas.openxmlformats.org/drawingml/2006/main">
             <a:r>
-              <a:t>第 10 课受限执行。屏显按现行逐页母稿压缩为课堂可读对象，完整说明保留在讲义与教师备注。</a:t>
+              <a:t>同伴提问，作者决定</a:t>
             </a:r>
           </a:p>
           <a:p xmlns:a="http://schemas.openxmlformats.org/drawingml/2006/main">
@@ -984,17 +1474,92 @@
           </a:p>
           <a:p xmlns:a="http://schemas.openxmlformats.org/drawingml/2006/main">
             <a:r>
+              <a:t>讲义对应：同伴互查 | 互查问题与作者决定</a:t>
+            </a:r>
+          </a:p>
+          <a:p xmlns:a="http://schemas.openxmlformats.org/drawingml/2006/main">
+            <a:r>
+              <a:t/>
+            </a:r>
+          </a:p>
+          <a:p xmlns:a="http://schemas.openxmlformats.org/drawingml/2006/main">
+            <a:r>
+              <a:t>[Teaching]</a:t>
+            </a:r>
+          </a:p>
+          <a:p xmlns:a="http://schemas.openxmlformats.org/drawingml/2006/main">
+            <a:r>
+              <a:t>作者先说明任务契约与 diff，同伴围绕五字段、修改范围、测试和失败记录提问。优先检查权限边界、人工审核是否真的停住、测试是否判定了目标行为。作者记录采纳、澄清、补证、保留异议或暂缓及真实理由；反馈不要求立即改写，也不形成共同提交。人数为奇数时组成三人组，适当缩短每人的说明。</a:t>
+            </a:r>
+          </a:p>
+          <a:p xmlns:a="http://schemas.openxmlformats.org/drawingml/2006/main">
+            <a:r>
+              <a:t/>
+            </a:r>
+          </a:p>
+          <a:p xmlns:a="http://schemas.openxmlformats.org/drawingml/2006/main">
+            <a:r>
+              <a:t>[Student action]</a:t>
+            </a:r>
+          </a:p>
+          <a:p xmlns:a="http://schemas.openxmlformats.org/drawingml/2006/main">
+            <a:r>
+              <a:t>同伴互查。</a:t>
+            </a:r>
+          </a:p>
+          <a:p xmlns:a="http://schemas.openxmlformats.org/drawingml/2006/main">
+            <a:r>
+              <a:t/>
+            </a:r>
+          </a:p>
+          <a:p xmlns:a="http://schemas.openxmlformats.org/drawingml/2006/main">
+            <a:r>
+              <a:t>[Timing]</a:t>
+            </a:r>
+          </a:p>
+          <a:p xmlns:a="http://schemas.openxmlformats.org/drawingml/2006/main">
+            <a:r>
+              <a:t>15 分钟。</a:t>
+            </a:r>
+          </a:p>
+          <a:p xmlns:a="http://schemas.openxmlformats.org/drawingml/2006/main">
+            <a:r>
+              <a:t/>
+            </a:r>
+          </a:p>
+          <a:p xmlns:a="http://schemas.openxmlformats.org/drawingml/2006/main">
+            <a:r>
+              <a:t>[Evidence boundary]</a:t>
+            </a:r>
+          </a:p>
+          <a:p xmlns:a="http://schemas.openxmlformats.org/drawingml/2006/main">
+            <a:r>
+              <a:t>同伴反馈为形成性活动，不单独计分，不共同提交（[assignments.md](../../course/assignments.md)）。</a:t>
+            </a:r>
+          </a:p>
+          <a:p xmlns:a="http://schemas.openxmlformats.org/drawingml/2006/main">
+            <a:r>
+              <a:t/>
+            </a:r>
+          </a:p>
+          <a:p xmlns:a="http://schemas.openxmlformats.org/drawingml/2006/main">
+            <a:r>
               <a:t>[Sources]</a:t>
             </a:r>
           </a:p>
           <a:p xmlns:a="http://schemas.openxmlformats.org/drawingml/2006/main">
             <a:r>
-              <a:t>- /Users/bright/Projects/courses/graduate/lessons/lesson-10/slides.md</a:t>
-            </a:r>
-          </a:p>
-          <a:p xmlns:a="http://schemas.openxmlformats.org/drawingml/2006/main">
-            <a:r>
-              <a:t>- /Users/bright/Projects/courses/graduate/lessons/lesson-10/handout.md</a:t>
+              <a:t>- lessons/lesson-10/slides.md P15</a:t>
+            </a:r>
+          </a:p>
+          <a:p xmlns:a="http://schemas.openxmlformats.org/drawingml/2006/main">
+            <a:r>
+              <a:t>- lessons/lesson-10/handout.md 同伴互查 | 互查问题与作者决定</a:t>
+            </a:r>
+          </a:p>
+          <a:p xmlns:a="http://schemas.openxmlformats.org/drawingml/2006/main">
+            <a:r>
+              <a:t>- lessons/lesson-10/teaching-plan.md</a:t>
             </a:r>
           </a:p>
           <a:p xmlns:a="http://schemas.openxmlformats.org/drawingml/2006/main">
@@ -1069,7 +1634,7 @@
           <a:lstStyle xmlns:a="http://schemas.openxmlformats.org/drawingml/2006/main"/>
           <a:p xmlns:a="http://schemas.openxmlformats.org/drawingml/2006/main">
             <a:r>
-              <a:t>第 10 课受限执行。屏显按现行逐页母稿压缩为课堂可读对象，完整说明保留在讲义与教师备注。</a:t>
+              <a:t>本讲知识点总结</a:t>
             </a:r>
           </a:p>
           <a:p xmlns:a="http://schemas.openxmlformats.org/drawingml/2006/main">
@@ -1079,17 +1644,92 @@
           </a:p>
           <a:p xmlns:a="http://schemas.openxmlformats.org/drawingml/2006/main">
             <a:r>
+              <a:t>讲义对应：§二-§六 本讲核心链路与边界总结</a:t>
+            </a:r>
+          </a:p>
+          <a:p xmlns:a="http://schemas.openxmlformats.org/drawingml/2006/main">
+            <a:r>
+              <a:t/>
+            </a:r>
+          </a:p>
+          <a:p xmlns:a="http://schemas.openxmlformats.org/drawingml/2006/main">
+            <a:r>
+              <a:t>[Teaching]</a:t>
+            </a:r>
+          </a:p>
+          <a:p xmlns:a="http://schemas.openxmlformats.org/drawingml/2006/main">
+            <a:r>
+              <a:t>回收任务契约、受限执行、diff/验证与失败保留的关系。本页不新增任务，要求学生用边界句检查自己的任务契约和执行记录。</a:t>
+            </a:r>
+          </a:p>
+          <a:p xmlns:a="http://schemas.openxmlformats.org/drawingml/2006/main">
+            <a:r>
+              <a:t/>
+            </a:r>
+          </a:p>
+          <a:p xmlns:a="http://schemas.openxmlformats.org/drawingml/2006/main">
+            <a:r>
+              <a:t>[Student action]</a:t>
+            </a:r>
+          </a:p>
+          <a:p xmlns:a="http://schemas.openxmlformats.org/drawingml/2006/main">
+            <a:r>
+              <a:t>学生快速指出自己当前最薄弱的一张卡。</a:t>
+            </a:r>
+          </a:p>
+          <a:p xmlns:a="http://schemas.openxmlformats.org/drawingml/2006/main">
+            <a:r>
+              <a:t/>
+            </a:r>
+          </a:p>
+          <a:p xmlns:a="http://schemas.openxmlformats.org/drawingml/2006/main">
+            <a:r>
+              <a:t>[Timing]</a:t>
+            </a:r>
+          </a:p>
+          <a:p xmlns:a="http://schemas.openxmlformats.org/drawingml/2006/main">
+            <a:r>
+              <a:t>2 分钟。</a:t>
+            </a:r>
+          </a:p>
+          <a:p xmlns:a="http://schemas.openxmlformats.org/drawingml/2006/main">
+            <a:r>
+              <a:t/>
+            </a:r>
+          </a:p>
+          <a:p xmlns:a="http://schemas.openxmlformats.org/drawingml/2006/main">
+            <a:r>
+              <a:t>[Evidence boundary]</a:t>
+            </a:r>
+          </a:p>
+          <a:p xmlns:a="http://schemas.openxmlformats.org/drawingml/2006/main">
+            <a:r>
+              <a:t>[handout.md](./handout.md) §二-§六；[teaching-plan.md](./teaching-plan.md) 第四至六节。</a:t>
+            </a:r>
+          </a:p>
+          <a:p xmlns:a="http://schemas.openxmlformats.org/drawingml/2006/main">
+            <a:r>
+              <a:t/>
+            </a:r>
+          </a:p>
+          <a:p xmlns:a="http://schemas.openxmlformats.org/drawingml/2006/main">
+            <a:r>
               <a:t>[Sources]</a:t>
             </a:r>
           </a:p>
           <a:p xmlns:a="http://schemas.openxmlformats.org/drawingml/2006/main">
             <a:r>
-              <a:t>- /Users/bright/Projects/courses/graduate/lessons/lesson-10/slides.md</a:t>
-            </a:r>
-          </a:p>
-          <a:p xmlns:a="http://schemas.openxmlformats.org/drawingml/2006/main">
-            <a:r>
-              <a:t>- /Users/bright/Projects/courses/graduate/lessons/lesson-10/handout.md</a:t>
+              <a:t>- lessons/lesson-10/slides.md P16</a:t>
+            </a:r>
+          </a:p>
+          <a:p xmlns:a="http://schemas.openxmlformats.org/drawingml/2006/main">
+            <a:r>
+              <a:t>- lessons/lesson-10/handout.md §二-§六 本讲核心链路与边界总结</a:t>
+            </a:r>
+          </a:p>
+          <a:p xmlns:a="http://schemas.openxmlformats.org/drawingml/2006/main">
+            <a:r>
+              <a:t>- lessons/lesson-10/teaching-plan.md</a:t>
             </a:r>
           </a:p>
           <a:p xmlns:a="http://schemas.openxmlformats.org/drawingml/2006/main">
@@ -1164,7 +1804,7 @@
           <a:lstStyle xmlns:a="http://schemas.openxmlformats.org/drawingml/2006/main"/>
           <a:p xmlns:a="http://schemas.openxmlformats.org/drawingml/2006/main">
             <a:r>
-              <a:t>第 10 课受限执行。屏显按现行逐页母稿压缩为课堂可读对象，完整说明保留在讲义与教师备注。</a:t>
+              <a:t>受限执行能否安全重复？</a:t>
             </a:r>
           </a:p>
           <a:p xmlns:a="http://schemas.openxmlformats.org/drawingml/2006/main">
@@ -1174,17 +1814,117 @@
           </a:p>
           <a:p xmlns:a="http://schemas.openxmlformats.org/drawingml/2006/main">
             <a:r>
+              <a:t>讲义对应：§六 常见错误；§导读 第 11 课预告；退出卡</a:t>
+            </a:r>
+          </a:p>
+          <a:p xmlns:a="http://schemas.openxmlformats.org/drawingml/2006/main">
+            <a:r>
+              <a:t/>
+            </a:r>
+          </a:p>
+          <a:p xmlns:a="http://schemas.openxmlformats.org/drawingml/2006/main">
+            <a:r>
+              <a:t>[Teaching]</a:t>
+            </a:r>
+          </a:p>
+          <a:p xmlns:a="http://schemas.openxmlformats.org/drawingml/2006/main">
+            <a:r>
+              <a:t>回扣本课目标：任务契约、可核验 diff、验证证据、失败或越权处理和 AI 使用记录共同构成第 11 课输入。第 11 课将一次受限执行扩展为冻结运行队列，约束固定指标、预算、停止条件和失败恢复；另行分析优化循环的 Keep/Discard，不能据结果筛除冻结评价队列的输出。本课非正式提交门，产出回写个人项目。</a:t>
+            </a:r>
+          </a:p>
+          <a:p xmlns:a="http://schemas.openxmlformats.org/drawingml/2006/main">
+            <a:r>
+              <a:t/>
+            </a:r>
+          </a:p>
+          <a:p xmlns:a="http://schemas.openxmlformats.org/drawingml/2006/main">
+            <a:r>
+              <a:t>[Student action]</a:t>
+            </a:r>
+          </a:p>
+          <a:p xmlns:a="http://schemas.openxmlformats.org/drawingml/2006/main">
+            <a:r>
+              <a:t>学生提交退出卡或保存在个人项目。教师收集共性问题，用于第 11 课前调整。</a:t>
+            </a:r>
+          </a:p>
+          <a:p xmlns:a="http://schemas.openxmlformats.org/drawingml/2006/main">
+            <a:r>
+              <a:t/>
+            </a:r>
+          </a:p>
+          <a:p xmlns:a="http://schemas.openxmlformats.org/drawingml/2006/main">
+            <a:r>
+              <a:t>[Timing]</a:t>
+            </a:r>
+          </a:p>
+          <a:p xmlns:a="http://schemas.openxmlformats.org/drawingml/2006/main">
+            <a:r>
+              <a:t>3 分钟。</a:t>
+            </a:r>
+          </a:p>
+          <a:p xmlns:a="http://schemas.openxmlformats.org/drawingml/2006/main">
+            <a:r>
+              <a:t/>
+            </a:r>
+          </a:p>
+          <a:p xmlns:a="http://schemas.openxmlformats.org/drawingml/2006/main">
+            <a:r>
+              <a:t>[Evidence boundary]</a:t>
+            </a:r>
+          </a:p>
+          <a:p xmlns:a="http://schemas.openxmlformats.org/drawingml/2006/main">
+            <a:r>
+              <a:t>- Russell, S., &amp; Norvig, P. *Artificial Intelligence: A Modern Approach*, 4th ed. Pearson, 2020, Ch 2. [出版社页面](https://www.pearson.com/en-us/subject-catalog/p/artificial-intelligence-a-modern-approach/P200000003500/9780134610993)。</a:t>
+            </a:r>
+          </a:p>
+          <a:p xmlns:a="http://schemas.openxmlformats.org/drawingml/2006/main">
+            <a:r>
+              <a:t>- Yao, S. et al. "ReAct: Synergizing Reasoning and Acting in Language Models." *ICLR 2023*. [会议页面](https://iclr.cc/virtual/2023/poster/11003)。</a:t>
+            </a:r>
+          </a:p>
+          <a:p xmlns:a="http://schemas.openxmlformats.org/drawingml/2006/main">
+            <a:r>
+              <a:t>- Amershi, S. et al. "Guidelines for Human-AI Interaction." *CHI 2019*. DOI: [10.1145/3290605.3300233](https://www.microsoft.com/en-us/research/publication/guidelines-for-human-ai-interaction/)。</a:t>
+            </a:r>
+          </a:p>
+          <a:p xmlns:a="http://schemas.openxmlformats.org/drawingml/2006/main">
+            <a:r>
+              <a:t>- Jimenez, C. E. et al. *SWE-bench*, ICLR 2024. [项目页面](https://www.swebench.com/original.html)。</a:t>
+            </a:r>
+          </a:p>
+          <a:p xmlns:a="http://schemas.openxmlformats.org/drawingml/2006/main">
+            <a:r>
+              <a:t>- 阅读规则见 [reading-list.md](../../course/reading-list.md) 第 10 课。</a:t>
+            </a:r>
+          </a:p>
+          <a:p xmlns:a="http://schemas.openxmlformats.org/drawingml/2006/main">
+            <a:r>
+              <a:t>- 本课非正式提交门（[assignments.md](../../course/assignments.md)）。</a:t>
+            </a:r>
+          </a:p>
+          <a:p xmlns:a="http://schemas.openxmlformats.org/drawingml/2006/main">
+            <a:r>
+              <a:t/>
+            </a:r>
+          </a:p>
+          <a:p xmlns:a="http://schemas.openxmlformats.org/drawingml/2006/main">
+            <a:r>
               <a:t>[Sources]</a:t>
             </a:r>
           </a:p>
           <a:p xmlns:a="http://schemas.openxmlformats.org/drawingml/2006/main">
             <a:r>
-              <a:t>- /Users/bright/Projects/courses/graduate/lessons/lesson-10/slides.md</a:t>
-            </a:r>
-          </a:p>
-          <a:p xmlns:a="http://schemas.openxmlformats.org/drawingml/2006/main">
-            <a:r>
-              <a:t>- /Users/bright/Projects/courses/graduate/lessons/lesson-10/handout.md</a:t>
+              <a:t>- lessons/lesson-10/slides.md P17</a:t>
+            </a:r>
+          </a:p>
+          <a:p xmlns:a="http://schemas.openxmlformats.org/drawingml/2006/main">
+            <a:r>
+              <a:t>- lessons/lesson-10/handout.md §六 常见错误；§导读 第 11 课预告；退出卡</a:t>
+            </a:r>
+          </a:p>
+          <a:p xmlns:a="http://schemas.openxmlformats.org/drawingml/2006/main">
+            <a:r>
+              <a:t>- lessons/lesson-10/teaching-plan.md</a:t>
             </a:r>
           </a:p>
           <a:p xmlns:a="http://schemas.openxmlformats.org/drawingml/2006/main">
@@ -1259,7 +1999,7 @@
           <a:lstStyle xmlns:a="http://schemas.openxmlformats.org/drawingml/2006/main"/>
           <a:p xmlns:a="http://schemas.openxmlformats.org/drawingml/2006/main">
             <a:r>
-              <a:t>第 10 课受限执行。屏显按现行逐页母稿压缩为课堂可读对象，完整说明保留在讲义与教师备注。</a:t>
+              <a:t>实验规格还没有约束 Agent 执行</a:t>
             </a:r>
           </a:p>
           <a:p xmlns:a="http://schemas.openxmlformats.org/drawingml/2006/main">
@@ -1269,17 +2009,92 @@
           </a:p>
           <a:p xmlns:a="http://schemas.openxmlformats.org/drawingml/2006/main">
             <a:r>
+              <a:t>讲义对应：§一 受限 Agent 执行在研究链路中的位置；§导读（承接第 9 课）；§学习目标</a:t>
+            </a:r>
+          </a:p>
+          <a:p xmlns:a="http://schemas.openxmlformats.org/drawingml/2006/main">
+            <a:r>
+              <a:t/>
+            </a:r>
+          </a:p>
+          <a:p xmlns:a="http://schemas.openxmlformats.org/drawingml/2006/main">
+            <a:r>
+              <a:t>[Teaching]</a:t>
+            </a:r>
+          </a:p>
+          <a:p xmlns:a="http://schemas.openxmlformats.org/drawingml/2006/main">
+            <a:r>
+              <a:t>回扣第 9 课：判断门已过，实验规格中"哪些步骤拟用 Agent、哪些步骤必须人工"是本课任务契约的直接输入。本课把"拟用 Agent"步骤改写为带验收标准的任务契约，让 Agent 在受限权限下执行一次。明确边界：目标是完成一次受限 Agent 执行的可复盘链路，不要求把 baseline 跑到最优；产出回写个人项目，作为第 13 课验证门材料的过程证据。第 11 课把本课的"一次执行"扩展为冻结队列执行与失败恢复。</a:t>
+            </a:r>
+          </a:p>
+          <a:p xmlns:a="http://schemas.openxmlformats.org/drawingml/2006/main">
+            <a:r>
+              <a:t/>
+            </a:r>
+          </a:p>
+          <a:p xmlns:a="http://schemas.openxmlformats.org/drawingml/2006/main">
+            <a:r>
+              <a:t>[Student action]</a:t>
+            </a:r>
+          </a:p>
+          <a:p xmlns:a="http://schemas.openxmlformats.org/drawingml/2006/main">
+            <a:r>
+              <a:t>快问：你第 9 课实验规格中标注了几个"拟用 Agent"步骤？只听回答，不评价。</a:t>
+            </a:r>
+          </a:p>
+          <a:p xmlns:a="http://schemas.openxmlformats.org/drawingml/2006/main">
+            <a:r>
+              <a:t/>
+            </a:r>
+          </a:p>
+          <a:p xmlns:a="http://schemas.openxmlformats.org/drawingml/2006/main">
+            <a:r>
+              <a:t>[Timing]</a:t>
+            </a:r>
+          </a:p>
+          <a:p xmlns:a="http://schemas.openxmlformats.org/drawingml/2006/main">
+            <a:r>
+              <a:t>5 分钟。</a:t>
+            </a:r>
+          </a:p>
+          <a:p xmlns:a="http://schemas.openxmlformats.org/drawingml/2006/main">
+            <a:r>
+              <a:t/>
+            </a:r>
+          </a:p>
+          <a:p xmlns:a="http://schemas.openxmlformats.org/drawingml/2006/main">
+            <a:r>
+              <a:t>[Evidence boundary]</a:t>
+            </a:r>
+          </a:p>
+          <a:p xmlns:a="http://schemas.openxmlformats.org/drawingml/2006/main">
+            <a:r>
+              <a:t>回扣第 9 课讲义 §三·5 与 §五；[备课规划.md](../备课规划.md) 第 10 课目标段；[assignments.md](../../course/assignments.md)（第 10 课非正式提交门）；[AGENTS.md](../../AGENTS.md) 证据标准。</a:t>
+            </a:r>
+          </a:p>
+          <a:p xmlns:a="http://schemas.openxmlformats.org/drawingml/2006/main">
+            <a:r>
+              <a:t/>
+            </a:r>
+          </a:p>
+          <a:p xmlns:a="http://schemas.openxmlformats.org/drawingml/2006/main">
+            <a:r>
               <a:t>[Sources]</a:t>
             </a:r>
           </a:p>
           <a:p xmlns:a="http://schemas.openxmlformats.org/drawingml/2006/main">
             <a:r>
-              <a:t>- /Users/bright/Projects/courses/graduate/lessons/lesson-10/slides.md</a:t>
-            </a:r>
-          </a:p>
-          <a:p xmlns:a="http://schemas.openxmlformats.org/drawingml/2006/main">
-            <a:r>
-              <a:t>- /Users/bright/Projects/courses/graduate/lessons/lesson-10/handout.md</a:t>
+              <a:t>- lessons/lesson-10/slides.md P02</a:t>
+            </a:r>
+          </a:p>
+          <a:p xmlns:a="http://schemas.openxmlformats.org/drawingml/2006/main">
+            <a:r>
+              <a:t>- lessons/lesson-10/handout.md §一 受限 Agent 执行在研究链路中的位置；§导读（承接第 9 课）；§学习目标</a:t>
+            </a:r>
+          </a:p>
+          <a:p xmlns:a="http://schemas.openxmlformats.org/drawingml/2006/main">
+            <a:r>
+              <a:t>- lessons/lesson-10/teaching-plan.md</a:t>
             </a:r>
           </a:p>
           <a:p xmlns:a="http://schemas.openxmlformats.org/drawingml/2006/main">
@@ -1354,7 +2169,7 @@
           <a:lstStyle xmlns:a="http://schemas.openxmlformats.org/drawingml/2006/main"/>
           <a:p xmlns:a="http://schemas.openxmlformats.org/drawingml/2006/main">
             <a:r>
-              <a:t>第 10 课受限执行。屏显按现行逐页母稿压缩为课堂可读对象，完整说明保留在讲义与教师备注。</a:t>
+              <a:t>模糊 prompt 让错误无法追溯</a:t>
             </a:r>
           </a:p>
           <a:p xmlns:a="http://schemas.openxmlformats.org/drawingml/2006/main">
@@ -1364,17 +2179,92 @@
           </a:p>
           <a:p xmlns:a="http://schemas.openxmlformats.org/drawingml/2006/main">
             <a:r>
+              <a:t>讲义对应：§二·1 模糊 prompt 的问题</a:t>
+            </a:r>
+          </a:p>
+          <a:p xmlns:a="http://schemas.openxmlformats.org/drawingml/2006/main">
+            <a:r>
+              <a:t/>
+            </a:r>
+          </a:p>
+          <a:p xmlns:a="http://schemas.openxmlformats.org/drawingml/2006/main">
+            <a:r>
+              <a:t>[Teaching]</a:t>
+            </a:r>
+          </a:p>
+          <a:p xmlns:a="http://schemas.openxmlformats.org/drawingml/2006/main">
+            <a:r>
+              <a:t>模糊 prompt 把范围、权限、验收、失败处理都交给 Agent 解释。核心问题是出错后无法追溯——研究者不知道 Agent 做了什么、为什么做、依据什么标准，因此无法判断结果是否仍属于当前实验。本课的起点是把模糊 prompt 改写为任务契约。</a:t>
+            </a:r>
+          </a:p>
+          <a:p xmlns:a="http://schemas.openxmlformats.org/drawingml/2006/main">
+            <a:r>
+              <a:t/>
+            </a:r>
+          </a:p>
+          <a:p xmlns:a="http://schemas.openxmlformats.org/drawingml/2006/main">
+            <a:r>
+              <a:t>[Student action]</a:t>
+            </a:r>
+          </a:p>
+          <a:p xmlns:a="http://schemas.openxmlformats.org/drawingml/2006/main">
+            <a:r>
+              <a:t>让学生说出自己最近一次给 Agent 的 prompt 属于模糊 prompt 的哪些特征。</a:t>
+            </a:r>
+          </a:p>
+          <a:p xmlns:a="http://schemas.openxmlformats.org/drawingml/2006/main">
+            <a:r>
+              <a:t/>
+            </a:r>
+          </a:p>
+          <a:p xmlns:a="http://schemas.openxmlformats.org/drawingml/2006/main">
+            <a:r>
+              <a:t>[Timing]</a:t>
+            </a:r>
+          </a:p>
+          <a:p xmlns:a="http://schemas.openxmlformats.org/drawingml/2006/main">
+            <a:r>
+              <a:t>4 分钟。</a:t>
+            </a:r>
+          </a:p>
+          <a:p xmlns:a="http://schemas.openxmlformats.org/drawingml/2006/main">
+            <a:r>
+              <a:t/>
+            </a:r>
+          </a:p>
+          <a:p xmlns:a="http://schemas.openxmlformats.org/drawingml/2006/main">
+            <a:r>
+              <a:t>[Evidence boundary]</a:t>
+            </a:r>
+          </a:p>
+          <a:p xmlns:a="http://schemas.openxmlformats.org/drawingml/2006/main">
+            <a:r>
+              <a:t>讲义 §二·1。</a:t>
+            </a:r>
+          </a:p>
+          <a:p xmlns:a="http://schemas.openxmlformats.org/drawingml/2006/main">
+            <a:r>
+              <a:t/>
+            </a:r>
+          </a:p>
+          <a:p xmlns:a="http://schemas.openxmlformats.org/drawingml/2006/main">
+            <a:r>
               <a:t>[Sources]</a:t>
             </a:r>
           </a:p>
           <a:p xmlns:a="http://schemas.openxmlformats.org/drawingml/2006/main">
             <a:r>
-              <a:t>- /Users/bright/Projects/courses/graduate/lessons/lesson-10/slides.md</a:t>
-            </a:r>
-          </a:p>
-          <a:p xmlns:a="http://schemas.openxmlformats.org/drawingml/2006/main">
-            <a:r>
-              <a:t>- /Users/bright/Projects/courses/graduate/lessons/lesson-10/handout.md</a:t>
+              <a:t>- lessons/lesson-10/slides.md P03</a:t>
+            </a:r>
+          </a:p>
+          <a:p xmlns:a="http://schemas.openxmlformats.org/drawingml/2006/main">
+            <a:r>
+              <a:t>- lessons/lesson-10/handout.md §二·1 模糊 prompt 的问题</a:t>
+            </a:r>
+          </a:p>
+          <a:p xmlns:a="http://schemas.openxmlformats.org/drawingml/2006/main">
+            <a:r>
+              <a:t>- lessons/lesson-10/teaching-plan.md</a:t>
             </a:r>
           </a:p>
           <a:p xmlns:a="http://schemas.openxmlformats.org/drawingml/2006/main">
@@ -1449,7 +2339,7 @@
           <a:lstStyle xmlns:a="http://schemas.openxmlformats.org/drawingml/2006/main"/>
           <a:p xmlns:a="http://schemas.openxmlformats.org/drawingml/2006/main">
             <a:r>
-              <a:t>第 10 课受限执行。屏显按现行逐页母稿压缩为课堂可读对象，完整说明保留在讲义与教师备注。</a:t>
+              <a:t>任务契约建立可检查边界</a:t>
             </a:r>
           </a:p>
           <a:p xmlns:a="http://schemas.openxmlformats.org/drawingml/2006/main">
@@ -1459,17 +2349,92 @@
           </a:p>
           <a:p xmlns:a="http://schemas.openxmlformats.org/drawingml/2006/main">
             <a:r>
+              <a:t>讲义对应：§二·2 任务契约五字段</a:t>
+            </a:r>
+          </a:p>
+          <a:p xmlns:a="http://schemas.openxmlformats.org/drawingml/2006/main">
+            <a:r>
+              <a:t/>
+            </a:r>
+          </a:p>
+          <a:p xmlns:a="http://schemas.openxmlformats.org/drawingml/2006/main">
+            <a:r>
+              <a:t>[Teaching]</a:t>
+            </a:r>
+          </a:p>
+          <a:p xmlns:a="http://schemas.openxmlformats.org/drawingml/2006/main">
+            <a:r>
+              <a:t>五字段必须落到贯穿案例样例。重点演示：Context 不暴露最终 rubric 评分（防止 Agent 调整实现以迎合评分）；Permission 可写层只含 `src/generate.py`；Non-goal 防止任务膨胀；人工审核点是"停下来等确认"；失败恢复不重试到成功。任务契约写在项目里（`agent-tasks/&lt;task-id&gt;.md`），与 diff、日志、人工核验一起留存。</a:t>
+            </a:r>
+          </a:p>
+          <a:p xmlns:a="http://schemas.openxmlformats.org/drawingml/2006/main">
+            <a:r>
+              <a:t/>
+            </a:r>
+          </a:p>
+          <a:p xmlns:a="http://schemas.openxmlformats.org/drawingml/2006/main">
+            <a:r>
+              <a:t>[Student action]</a:t>
+            </a:r>
+          </a:p>
+          <a:p xmlns:a="http://schemas.openxmlformats.org/drawingml/2006/main">
+            <a:r>
+              <a:t>让学生用自己的"拟用 Agent"步骤尝试填写五字段。</a:t>
+            </a:r>
+          </a:p>
+          <a:p xmlns:a="http://schemas.openxmlformats.org/drawingml/2006/main">
+            <a:r>
+              <a:t/>
+            </a:r>
+          </a:p>
+          <a:p xmlns:a="http://schemas.openxmlformats.org/drawingml/2006/main">
+            <a:r>
+              <a:t>[Timing]</a:t>
+            </a:r>
+          </a:p>
+          <a:p xmlns:a="http://schemas.openxmlformats.org/drawingml/2006/main">
+            <a:r>
+              <a:t>4 分钟。</a:t>
+            </a:r>
+          </a:p>
+          <a:p xmlns:a="http://schemas.openxmlformats.org/drawingml/2006/main">
+            <a:r>
+              <a:t/>
+            </a:r>
+          </a:p>
+          <a:p xmlns:a="http://schemas.openxmlformats.org/drawingml/2006/main">
+            <a:r>
+              <a:t>[Evidence boundary]</a:t>
+            </a:r>
+          </a:p>
+          <a:p xmlns:a="http://schemas.openxmlformats.org/drawingml/2006/main">
+            <a:r>
+              <a:t>讲义 §二·2；Russell &amp; Norvig 2020 Ch 2（[reading-list.md](../../course/reading-list.md) 第 10 课）。</a:t>
+            </a:r>
+          </a:p>
+          <a:p xmlns:a="http://schemas.openxmlformats.org/drawingml/2006/main">
+            <a:r>
+              <a:t/>
+            </a:r>
+          </a:p>
+          <a:p xmlns:a="http://schemas.openxmlformats.org/drawingml/2006/main">
+            <a:r>
               <a:t>[Sources]</a:t>
             </a:r>
           </a:p>
           <a:p xmlns:a="http://schemas.openxmlformats.org/drawingml/2006/main">
             <a:r>
-              <a:t>- /Users/bright/Projects/courses/graduate/lessons/lesson-10/slides.md</a:t>
-            </a:r>
-          </a:p>
-          <a:p xmlns:a="http://schemas.openxmlformats.org/drawingml/2006/main">
-            <a:r>
-              <a:t>- /Users/bright/Projects/courses/graduate/lessons/lesson-10/handout.md</a:t>
+              <a:t>- lessons/lesson-10/slides.md P04</a:t>
+            </a:r>
+          </a:p>
+          <a:p xmlns:a="http://schemas.openxmlformats.org/drawingml/2006/main">
+            <a:r>
+              <a:t>- lessons/lesson-10/handout.md §二·2 任务契约五字段</a:t>
+            </a:r>
+          </a:p>
+          <a:p xmlns:a="http://schemas.openxmlformats.org/drawingml/2006/main">
+            <a:r>
+              <a:t>- lessons/lesson-10/teaching-plan.md</a:t>
             </a:r>
           </a:p>
           <a:p xmlns:a="http://schemas.openxmlformats.org/drawingml/2006/main">
@@ -1544,7 +2509,7 @@
           <a:lstStyle xmlns:a="http://schemas.openxmlformats.org/drawingml/2006/main"/>
           <a:p xmlns:a="http://schemas.openxmlformats.org/drawingml/2006/main">
             <a:r>
-              <a:t>第 10 课受限执行。屏显按现行逐页母稿压缩为课堂可读对象，完整说明保留在讲义与教师备注。</a:t>
+              <a:t>任务契约把请求改写为可追溯执行</a:t>
             </a:r>
           </a:p>
           <a:p xmlns:a="http://schemas.openxmlformats.org/drawingml/2006/main">
@@ -1554,17 +2519,92 @@
           </a:p>
           <a:p xmlns:a="http://schemas.openxmlformats.org/drawingml/2006/main">
             <a:r>
+              <a:t>讲义对应：§二·3 模糊 prompt 与任务契约的对照</a:t>
+            </a:r>
+          </a:p>
+          <a:p xmlns:a="http://schemas.openxmlformats.org/drawingml/2006/main">
+            <a:r>
+              <a:t/>
+            </a:r>
+          </a:p>
+          <a:p xmlns:a="http://schemas.openxmlformats.org/drawingml/2006/main">
+            <a:r>
+              <a:t>[Teaching]</a:t>
+            </a:r>
+          </a:p>
+          <a:p xmlns:a="http://schemas.openxmlformats.org/drawingml/2006/main">
+            <a:r>
+              <a:t>屏显按范围、权限、验收与失败处理四个方面比较原请求和任务契约；可追溯性由这些约束与日志共同建立。独立检查者应能从契约、diff、测试和失败记录复核本次执行。</a:t>
+            </a:r>
+          </a:p>
+          <a:p xmlns:a="http://schemas.openxmlformats.org/drawingml/2006/main">
+            <a:r>
+              <a:t/>
+            </a:r>
+          </a:p>
+          <a:p xmlns:a="http://schemas.openxmlformats.org/drawingml/2006/main">
+            <a:r>
+              <a:t>[Student action]</a:t>
+            </a:r>
+          </a:p>
+          <a:p xmlns:a="http://schemas.openxmlformats.org/drawingml/2006/main">
+            <a:r>
+              <a:t>让学生用对照表检查自己刚才写的五字段，标注哪些维度仍模糊。</a:t>
+            </a:r>
+          </a:p>
+          <a:p xmlns:a="http://schemas.openxmlformats.org/drawingml/2006/main">
+            <a:r>
+              <a:t/>
+            </a:r>
+          </a:p>
+          <a:p xmlns:a="http://schemas.openxmlformats.org/drawingml/2006/main">
+            <a:r>
+              <a:t>[Timing]</a:t>
+            </a:r>
+          </a:p>
+          <a:p xmlns:a="http://schemas.openxmlformats.org/drawingml/2006/main">
+            <a:r>
+              <a:t>4 分钟。</a:t>
+            </a:r>
+          </a:p>
+          <a:p xmlns:a="http://schemas.openxmlformats.org/drawingml/2006/main">
+            <a:r>
+              <a:t/>
+            </a:r>
+          </a:p>
+          <a:p xmlns:a="http://schemas.openxmlformats.org/drawingml/2006/main">
+            <a:r>
+              <a:t>[Evidence boundary]</a:t>
+            </a:r>
+          </a:p>
+          <a:p xmlns:a="http://schemas.openxmlformats.org/drawingml/2006/main">
+            <a:r>
+              <a:t>讲义 §二·3；Russell &amp; Norvig 2020 Ch 2（[reading-list.md](../../course/reading-list.md) 第 10 课）。</a:t>
+            </a:r>
+          </a:p>
+          <a:p xmlns:a="http://schemas.openxmlformats.org/drawingml/2006/main">
+            <a:r>
+              <a:t/>
+            </a:r>
+          </a:p>
+          <a:p xmlns:a="http://schemas.openxmlformats.org/drawingml/2006/main">
+            <a:r>
               <a:t>[Sources]</a:t>
             </a:r>
           </a:p>
           <a:p xmlns:a="http://schemas.openxmlformats.org/drawingml/2006/main">
             <a:r>
-              <a:t>- /Users/bright/Projects/courses/graduate/lessons/lesson-10/slides.md</a:t>
-            </a:r>
-          </a:p>
-          <a:p xmlns:a="http://schemas.openxmlformats.org/drawingml/2006/main">
-            <a:r>
-              <a:t>- /Users/bright/Projects/courses/graduate/lessons/lesson-10/handout.md</a:t>
+              <a:t>- lessons/lesson-10/slides.md P05</a:t>
+            </a:r>
+          </a:p>
+          <a:p xmlns:a="http://schemas.openxmlformats.org/drawingml/2006/main">
+            <a:r>
+              <a:t>- lessons/lesson-10/handout.md §二·3 模糊 prompt 与任务契约的对照</a:t>
+            </a:r>
+          </a:p>
+          <a:p xmlns:a="http://schemas.openxmlformats.org/drawingml/2006/main">
+            <a:r>
+              <a:t>- lessons/lesson-10/teaching-plan.md</a:t>
             </a:r>
           </a:p>
           <a:p xmlns:a="http://schemas.openxmlformats.org/drawingml/2006/main">
@@ -1639,7 +2679,7 @@
           <a:lstStyle xmlns:a="http://schemas.openxmlformats.org/drawingml/2006/main"/>
           <a:p xmlns:a="http://schemas.openxmlformats.org/drawingml/2006/main">
             <a:r>
-              <a:t>第 10 课受限执行。屏显按现行逐页母稿压缩为课堂可读对象，完整说明保留在讲义与教师备注。</a:t>
+              <a:t>任务级权限与真正停住的审核点</a:t>
             </a:r>
           </a:p>
           <a:p xmlns:a="http://schemas.openxmlformats.org/drawingml/2006/main">
@@ -1649,17 +2689,107 @@
           </a:p>
           <a:p xmlns:a="http://schemas.openxmlformats.org/drawingml/2006/main">
             <a:r>
+              <a:t>讲义对应：§三·1 最小权限原则的回归；§三·2 人工审核点的位置</a:t>
+            </a:r>
+          </a:p>
+          <a:p xmlns:a="http://schemas.openxmlformats.org/drawingml/2006/main">
+            <a:r>
+              <a:t/>
+            </a:r>
+          </a:p>
+          <a:p xmlns:a="http://schemas.openxmlformats.org/drawingml/2006/main">
+            <a:r>
+              <a:t>[Teaching]</a:t>
+            </a:r>
+          </a:p>
+          <a:p xmlns:a="http://schemas.openxmlformats.org/drawingml/2006/main">
+            <a:r>
+              <a:t>本课把最小权限从项目级落到任务级，任务结束后收回权限。屏显 configs/rubric 进入“需确认”表示提出变更时先停下：本次受限调试任务不能自行修改评价协议，获准变更也必须作为另一个研究决定更新规格并重新冻结，不能混入同一评价队列。结果、私有 notes 与外传仍属禁止范围。</a:t>
+            </a:r>
+          </a:p>
+          <a:p xmlns:a="http://schemas.openxmlformats.org/drawingml/2006/main">
+            <a:r>
+              <a:t/>
+            </a:r>
+          </a:p>
+          <a:p xmlns:a="http://schemas.openxmlformats.org/drawingml/2006/main">
+            <a:r>
+              <a:t>[Student action]</a:t>
+            </a:r>
+          </a:p>
+          <a:p xmlns:a="http://schemas.openxmlformats.org/drawingml/2006/main">
+            <a:r>
+              <a:t>让学生检查自己五字段中"可写"是否过宽——是否包含整个 `src/` 而不是具体文件？并标出至少四个审核点。</a:t>
+            </a:r>
+          </a:p>
+          <a:p xmlns:a="http://schemas.openxmlformats.org/drawingml/2006/main">
+            <a:r>
+              <a:t/>
+            </a:r>
+          </a:p>
+          <a:p xmlns:a="http://schemas.openxmlformats.org/drawingml/2006/main">
+            <a:r>
+              <a:t>[Timing]</a:t>
+            </a:r>
+          </a:p>
+          <a:p xmlns:a="http://schemas.openxmlformats.org/drawingml/2006/main">
+            <a:r>
+              <a:t>2 分钟。</a:t>
+            </a:r>
+          </a:p>
+          <a:p xmlns:a="http://schemas.openxmlformats.org/drawingml/2006/main">
+            <a:r>
+              <a:t/>
+            </a:r>
+          </a:p>
+          <a:p xmlns:a="http://schemas.openxmlformats.org/drawingml/2006/main">
+            <a:r>
+              <a:t>[Evidence boundary]</a:t>
+            </a:r>
+          </a:p>
+          <a:p xmlns:a="http://schemas.openxmlformats.org/drawingml/2006/main">
+            <a:r>
+              <a:t>直接来源：[正式来源](https://www.microsoft.com/en-us/research/publication/guidelines-for-human-ai-interaction/)。</a:t>
+            </a:r>
+          </a:p>
+          <a:p xmlns:a="http://schemas.openxmlformats.org/drawingml/2006/main">
+            <a:r>
+              <a:t/>
+            </a:r>
+          </a:p>
+          <a:p xmlns:a="http://schemas.openxmlformats.org/drawingml/2006/main">
+            <a:r>
+              <a:t>讲义 §三·1 与 §三·2；第 1 课 §四·3 最小权限原则；Amershi et al. CHI 2019（[reading-list.md](../../course/reading-list.md) 第 10 课）；第 9 课 §三·2 停止条件。</a:t>
+            </a:r>
+          </a:p>
+          <a:p xmlns:a="http://schemas.openxmlformats.org/drawingml/2006/main">
+            <a:r>
+              <a:t/>
+            </a:r>
+          </a:p>
+          <a:p xmlns:a="http://schemas.openxmlformats.org/drawingml/2006/main">
+            <a:r>
               <a:t>[Sources]</a:t>
             </a:r>
           </a:p>
           <a:p xmlns:a="http://schemas.openxmlformats.org/drawingml/2006/main">
             <a:r>
-              <a:t>- /Users/bright/Projects/courses/graduate/lessons/lesson-10/slides.md</a:t>
-            </a:r>
-          </a:p>
-          <a:p xmlns:a="http://schemas.openxmlformats.org/drawingml/2006/main">
-            <a:r>
-              <a:t>- /Users/bright/Projects/courses/graduate/lessons/lesson-10/handout.md</a:t>
+              <a:t>- lessons/lesson-10/slides.md P06</a:t>
+            </a:r>
+          </a:p>
+          <a:p xmlns:a="http://schemas.openxmlformats.org/drawingml/2006/main">
+            <a:r>
+              <a:t>- lessons/lesson-10/handout.md §三·1 最小权限原则的回归；§三·2 人工审核点的位置</a:t>
+            </a:r>
+          </a:p>
+          <a:p xmlns:a="http://schemas.openxmlformats.org/drawingml/2006/main">
+            <a:r>
+              <a:t>- lessons/lesson-10/teaching-plan.md</a:t>
+            </a:r>
+          </a:p>
+          <a:p xmlns:a="http://schemas.openxmlformats.org/drawingml/2006/main">
+            <a:r>
+              <a:t>- https://www.microsoft.com/en-us/research/publication/guidelines-for-human-ai-interaction/</a:t>
             </a:r>
           </a:p>
           <a:p xmlns:a="http://schemas.openxmlformats.org/drawingml/2006/main">
@@ -1734,7 +2864,7 @@
           <a:lstStyle xmlns:a="http://schemas.openxmlformats.org/drawingml/2006/main"/>
           <a:p xmlns:a="http://schemas.openxmlformats.org/drawingml/2006/main">
             <a:r>
-              <a:t>第 10 课受限执行。屏显按现行逐页母稿压缩为课堂可读对象，完整说明保留在讲义与教师备注。</a:t>
+              <a:t>错误循环需要可见的失败恢复</a:t>
             </a:r>
           </a:p>
           <a:p xmlns:a="http://schemas.openxmlformats.org/drawingml/2006/main">
@@ -1744,17 +2874,107 @@
           </a:p>
           <a:p xmlns:a="http://schemas.openxmlformats.org/drawingml/2006/main">
             <a:r>
+              <a:t>讲义对应：§二·4 ReAct 循环与错误传播；§三·3 为什么要预先写停止与确认；§三·4 失败恢复</a:t>
+            </a:r>
+          </a:p>
+          <a:p xmlns:a="http://schemas.openxmlformats.org/drawingml/2006/main">
+            <a:r>
+              <a:t/>
+            </a:r>
+          </a:p>
+          <a:p xmlns:a="http://schemas.openxmlformats.org/drawingml/2006/main">
+            <a:r>
+              <a:t>[Teaching]</a:t>
+            </a:r>
+          </a:p>
+          <a:p xmlns:a="http://schemas.openxmlformats.org/drawingml/2006/main">
+            <a:r>
+              <a:t>ReAct 循环说明 Agent 输出必须被核验：错误会在推理、行动、观察任一环节传播并自我强化。任务契约与日志让错误传播可被观察。失败恢复不重试到成功——失败日志与成功结果同等重要，删除失败日志等同于伪造实验记录（沿用 [assessment.md](../../course/assessment.md) 学术规范红线）。</a:t>
+            </a:r>
+          </a:p>
+          <a:p xmlns:a="http://schemas.openxmlformats.org/drawingml/2006/main">
+            <a:r>
+              <a:t/>
+            </a:r>
+          </a:p>
+          <a:p xmlns:a="http://schemas.openxmlformats.org/drawingml/2006/main">
+            <a:r>
+              <a:t>[Student action]</a:t>
+            </a:r>
+          </a:p>
+          <a:p xmlns:a="http://schemas.openxmlformats.org/drawingml/2006/main">
+            <a:r>
+              <a:t>让学生检查自己任务契约的失败恢复段是否覆盖超时、越权、测试失败三种情形。</a:t>
+            </a:r>
+          </a:p>
+          <a:p xmlns:a="http://schemas.openxmlformats.org/drawingml/2006/main">
+            <a:r>
+              <a:t/>
+            </a:r>
+          </a:p>
+          <a:p xmlns:a="http://schemas.openxmlformats.org/drawingml/2006/main">
+            <a:r>
+              <a:t>[Timing]</a:t>
+            </a:r>
+          </a:p>
+          <a:p xmlns:a="http://schemas.openxmlformats.org/drawingml/2006/main">
+            <a:r>
+              <a:t>2 分钟。</a:t>
+            </a:r>
+          </a:p>
+          <a:p xmlns:a="http://schemas.openxmlformats.org/drawingml/2006/main">
+            <a:r>
+              <a:t/>
+            </a:r>
+          </a:p>
+          <a:p xmlns:a="http://schemas.openxmlformats.org/drawingml/2006/main">
+            <a:r>
+              <a:t>[Evidence boundary]</a:t>
+            </a:r>
+          </a:p>
+          <a:p xmlns:a="http://schemas.openxmlformats.org/drawingml/2006/main">
+            <a:r>
+              <a:t>直接来源：[正式来源](https://iclr.cc/virtual/2023/poster/11003)。</a:t>
+            </a:r>
+          </a:p>
+          <a:p xmlns:a="http://schemas.openxmlformats.org/drawingml/2006/main">
+            <a:r>
+              <a:t/>
+            </a:r>
+          </a:p>
+          <a:p xmlns:a="http://schemas.openxmlformats.org/drawingml/2006/main">
+            <a:r>
+              <a:t>讲义 §二·4 与 §三·4；Yao et al. ReAct ICLR 2023（[reading-list.md](../../course/reading-list.md) 第 10 课）；[assessment.md](../../course/assessment.md) 学术规范红线。</a:t>
+            </a:r>
+          </a:p>
+          <a:p xmlns:a="http://schemas.openxmlformats.org/drawingml/2006/main">
+            <a:r>
+              <a:t/>
+            </a:r>
+          </a:p>
+          <a:p xmlns:a="http://schemas.openxmlformats.org/drawingml/2006/main">
+            <a:r>
               <a:t>[Sources]</a:t>
             </a:r>
           </a:p>
           <a:p xmlns:a="http://schemas.openxmlformats.org/drawingml/2006/main">
             <a:r>
-              <a:t>- /Users/bright/Projects/courses/graduate/lessons/lesson-10/slides.md</a:t>
-            </a:r>
-          </a:p>
-          <a:p xmlns:a="http://schemas.openxmlformats.org/drawingml/2006/main">
-            <a:r>
-              <a:t>- /Users/bright/Projects/courses/graduate/lessons/lesson-10/handout.md</a:t>
+              <a:t>- lessons/lesson-10/slides.md P07</a:t>
+            </a:r>
+          </a:p>
+          <a:p xmlns:a="http://schemas.openxmlformats.org/drawingml/2006/main">
+            <a:r>
+              <a:t>- lessons/lesson-10/handout.md §二·4 ReAct 循环与错误传播；§三·3 为什么要预先写停止与确认；§三·4 失败恢复</a:t>
+            </a:r>
+          </a:p>
+          <a:p xmlns:a="http://schemas.openxmlformats.org/drawingml/2006/main">
+            <a:r>
+              <a:t>- lessons/lesson-10/teaching-plan.md</a:t>
+            </a:r>
+          </a:p>
+          <a:p xmlns:a="http://schemas.openxmlformats.org/drawingml/2006/main">
+            <a:r>
+              <a:t>- https://iclr.cc/virtual/2023/poster/11003</a:t>
             </a:r>
           </a:p>
           <a:p xmlns:a="http://schemas.openxmlformats.org/drawingml/2006/main">
@@ -1829,7 +3049,7 @@
           <a:lstStyle xmlns:a="http://schemas.openxmlformats.org/drawingml/2006/main"/>
           <a:p xmlns:a="http://schemas.openxmlformats.org/drawingml/2006/main">
             <a:r>
-              <a:t>第 10 课受限执行。屏显按现行逐页母稿压缩为课堂可读对象，完整说明保留在讲义与教师备注。</a:t>
+              <a:t>用 diff 与测试审查候选实现</a:t>
             </a:r>
           </a:p>
           <a:p xmlns:a="http://schemas.openxmlformats.org/drawingml/2006/main">
@@ -1839,17 +3059,112 @@
           </a:p>
           <a:p xmlns:a="http://schemas.openxmlformats.org/drawingml/2006/main">
             <a:r>
+              <a:t>讲义对应：§四·1 Agent 输出是候选，不是事实；§四·3 diff 审查清单</a:t>
+            </a:r>
+          </a:p>
+          <a:p xmlns:a="http://schemas.openxmlformats.org/drawingml/2006/main">
+            <a:r>
+              <a:t/>
+            </a:r>
+          </a:p>
+          <a:p xmlns:a="http://schemas.openxmlformats.org/drawingml/2006/main">
+            <a:r>
+              <a:t>[Teaching]</a:t>
+            </a:r>
+          </a:p>
+          <a:p xmlns:a="http://schemas.openxmlformats.org/drawingml/2006/main">
+            <a:r>
+              <a:t>用本课真实 generate.diff 检查缺字段是否明确失败，再核对测试是否覆盖这一行为。屏显四项审核不能代替方法判断：baseline 公平性、指标定义与停止条件仍由研究者决定。后续 P14 的完整审查还会核对依赖、Non-goal 与提交说明是否只写事实。</a:t>
+            </a:r>
+          </a:p>
+          <a:p xmlns:a="http://schemas.openxmlformats.org/drawingml/2006/main">
+            <a:r>
+              <a:t/>
+            </a:r>
+          </a:p>
+          <a:p xmlns:a="http://schemas.openxmlformats.org/drawingml/2006/main">
+            <a:r>
+              <a:t>[Student action]</a:t>
+            </a:r>
+          </a:p>
+          <a:p xmlns:a="http://schemas.openxmlformats.org/drawingml/2006/main">
+            <a:r>
+              <a:t>让学生用贯穿案例的 diff 样例对照六项逐项检查。</a:t>
+            </a:r>
+          </a:p>
+          <a:p xmlns:a="http://schemas.openxmlformats.org/drawingml/2006/main">
+            <a:r>
+              <a:t/>
+            </a:r>
+          </a:p>
+          <a:p xmlns:a="http://schemas.openxmlformats.org/drawingml/2006/main">
+            <a:r>
+              <a:t>[Timing]</a:t>
+            </a:r>
+          </a:p>
+          <a:p xmlns:a="http://schemas.openxmlformats.org/drawingml/2006/main">
+            <a:r>
+              <a:t>3 分钟。</a:t>
+            </a:r>
+          </a:p>
+          <a:p xmlns:a="http://schemas.openxmlformats.org/drawingml/2006/main">
+            <a:r>
+              <a:t/>
+            </a:r>
+          </a:p>
+          <a:p xmlns:a="http://schemas.openxmlformats.org/drawingml/2006/main">
+            <a:r>
+              <a:t>[Evidence boundary]</a:t>
+            </a:r>
+          </a:p>
+          <a:p xmlns:a="http://schemas.openxmlformats.org/drawingml/2006/main">
+            <a:r>
+              <a:t>直接来源：[本课工件](assets/agent-task-example/generate.diff)；[本课工件](assets/agent-task-example/test-output.txt)。</a:t>
+            </a:r>
+          </a:p>
+          <a:p xmlns:a="http://schemas.openxmlformats.org/drawingml/2006/main">
+            <a:r>
+              <a:t/>
+            </a:r>
+          </a:p>
+          <a:p xmlns:a="http://schemas.openxmlformats.org/drawingml/2006/main">
+            <a:r>
+              <a:t>讲义 §四·1 与 §四·3；第 1 课 §一·2 哪些判断不能外包；[AGENTS.md](../../AGENTS.md) 证据标准。</a:t>
+            </a:r>
+          </a:p>
+          <a:p xmlns:a="http://schemas.openxmlformats.org/drawingml/2006/main">
+            <a:r>
+              <a:t/>
+            </a:r>
+          </a:p>
+          <a:p xmlns:a="http://schemas.openxmlformats.org/drawingml/2006/main">
+            <a:r>
               <a:t>[Sources]</a:t>
             </a:r>
           </a:p>
           <a:p xmlns:a="http://schemas.openxmlformats.org/drawingml/2006/main">
             <a:r>
-              <a:t>- /Users/bright/Projects/courses/graduate/lessons/lesson-10/slides.md</a:t>
-            </a:r>
-          </a:p>
-          <a:p xmlns:a="http://schemas.openxmlformats.org/drawingml/2006/main">
-            <a:r>
-              <a:t>- /Users/bright/Projects/courses/graduate/lessons/lesson-10/handout.md</a:t>
+              <a:t>- lessons/lesson-10/slides.md P08</a:t>
+            </a:r>
+          </a:p>
+          <a:p xmlns:a="http://schemas.openxmlformats.org/drawingml/2006/main">
+            <a:r>
+              <a:t>- lessons/lesson-10/handout.md §四·1 Agent 输出是候选，不是事实；§四·3 diff 审查清单</a:t>
+            </a:r>
+          </a:p>
+          <a:p xmlns:a="http://schemas.openxmlformats.org/drawingml/2006/main">
+            <a:r>
+              <a:t>- lessons/lesson-10/teaching-plan.md</a:t>
+            </a:r>
+          </a:p>
+          <a:p xmlns:a="http://schemas.openxmlformats.org/drawingml/2006/main">
+            <a:r>
+              <a:t>- assets/agent-task-example/generate.diff</a:t>
+            </a:r>
+          </a:p>
+          <a:p xmlns:a="http://schemas.openxmlformats.org/drawingml/2006/main">
+            <a:r>
+              <a:t>- assets/agent-task-example/test-output.txt</a:t>
             </a:r>
           </a:p>
           <a:p xmlns:a="http://schemas.openxmlformats.org/drawingml/2006/main">
@@ -1924,7 +3239,7 @@
           <a:lstStyle xmlns:a="http://schemas.openxmlformats.org/drawingml/2006/main"/>
           <a:p xmlns:a="http://schemas.openxmlformats.org/drawingml/2006/main">
             <a:r>
-              <a:t>第 10 课受限执行。屏显按现行逐页母稿压缩为课堂可读对象，完整说明保留在讲义与教师备注。</a:t>
+              <a:t>进入项目的修改需要根因与验证证据</a:t>
             </a:r>
           </a:p>
           <a:p xmlns:a="http://schemas.openxmlformats.org/drawingml/2006/main">
@@ -1934,17 +3249,92 @@
           </a:p>
           <a:p xmlns:a="http://schemas.openxmlformats.org/drawingml/2006/main">
             <a:r>
+              <a:t>讲义对应：§四·2 修复根因、绕过失败与污染实验</a:t>
+            </a:r>
+          </a:p>
+          <a:p xmlns:a="http://schemas.openxmlformats.org/drawingml/2006/main">
+            <a:r>
+              <a:t/>
+            </a:r>
+          </a:p>
+          <a:p xmlns:a="http://schemas.openxmlformats.org/drawingml/2006/main">
+            <a:r>
+              <a:t>[Teaching]</a:t>
+            </a:r>
+          </a:p>
+          <a:p xmlns:a="http://schemas.openxmlformats.org/drawingml/2006/main">
+            <a:r>
+              <a:t>三区分决定 Agent 提议能否进入当前实验版本。根因修复必须保留失败日志、diff 与根因分析；绕过建议应被拒绝并留痕；评价协议或 baseline 改动必须退出调试任务，作为新研究决定审核。强调技术失败与规范红线的边界。</a:t>
+            </a:r>
+          </a:p>
+          <a:p xmlns:a="http://schemas.openxmlformats.org/drawingml/2006/main">
+            <a:r>
+              <a:t/>
+            </a:r>
+          </a:p>
+          <a:p xmlns:a="http://schemas.openxmlformats.org/drawingml/2006/main">
+            <a:r>
+              <a:t>[Student action]</a:t>
+            </a:r>
+          </a:p>
+          <a:p xmlns:a="http://schemas.openxmlformats.org/drawingml/2006/main">
+            <a:r>
+              <a:t>让学生判断三段 diff 样例各属哪一类（教师提供）。</a:t>
+            </a:r>
+          </a:p>
+          <a:p xmlns:a="http://schemas.openxmlformats.org/drawingml/2006/main">
+            <a:r>
+              <a:t/>
+            </a:r>
+          </a:p>
+          <a:p xmlns:a="http://schemas.openxmlformats.org/drawingml/2006/main">
+            <a:r>
+              <a:t>[Timing]</a:t>
+            </a:r>
+          </a:p>
+          <a:p xmlns:a="http://schemas.openxmlformats.org/drawingml/2006/main">
+            <a:r>
+              <a:t>3 分钟。</a:t>
+            </a:r>
+          </a:p>
+          <a:p xmlns:a="http://schemas.openxmlformats.org/drawingml/2006/main">
+            <a:r>
+              <a:t/>
+            </a:r>
+          </a:p>
+          <a:p xmlns:a="http://schemas.openxmlformats.org/drawingml/2006/main">
+            <a:r>
+              <a:t>[Evidence boundary]</a:t>
+            </a:r>
+          </a:p>
+          <a:p xmlns:a="http://schemas.openxmlformats.org/drawingml/2006/main">
+            <a:r>
+              <a:t>讲义 §四·2；[assessment.md](../../course/assessment.md) 学术规范红线。</a:t>
+            </a:r>
+          </a:p>
+          <a:p xmlns:a="http://schemas.openxmlformats.org/drawingml/2006/main">
+            <a:r>
+              <a:t/>
+            </a:r>
+          </a:p>
+          <a:p xmlns:a="http://schemas.openxmlformats.org/drawingml/2006/main">
+            <a:r>
               <a:t>[Sources]</a:t>
             </a:r>
           </a:p>
           <a:p xmlns:a="http://schemas.openxmlformats.org/drawingml/2006/main">
             <a:r>
-              <a:t>- /Users/bright/Projects/courses/graduate/lessons/lesson-10/slides.md</a:t>
-            </a:r>
-          </a:p>
-          <a:p xmlns:a="http://schemas.openxmlformats.org/drawingml/2006/main">
-            <a:r>
-              <a:t>- /Users/bright/Projects/courses/graduate/lessons/lesson-10/handout.md</a:t>
+              <a:t>- lessons/lesson-10/slides.md P09</a:t>
+            </a:r>
+          </a:p>
+          <a:p xmlns:a="http://schemas.openxmlformats.org/drawingml/2006/main">
+            <a:r>
+              <a:t>- lessons/lesson-10/handout.md §四·2 修复根因、绕过失败与污染实验</a:t>
+            </a:r>
+          </a:p>
+          <a:p xmlns:a="http://schemas.openxmlformats.org/drawingml/2006/main">
+            <a:r>
+              <a:t>- lessons/lesson-10/teaching-plan.md</a:t>
             </a:r>
           </a:p>
           <a:p xmlns:a="http://schemas.openxmlformats.org/drawingml/2006/main">

</xml_diff>